<commit_message>
feat: implement self-hosted identity, MFA enrollment, CSRF protection, and user administration APIs
</commit_message>
<xml_diff>
--- a/doc/qa/mpr/MIS-Demo-MPR-Lagos-2026-10-10.pptx
+++ b/doc/qa/mpr/MIS-Demo-MPR-Lagos-2026-10-10.pptx
@@ -3591,7 +3591,7 @@
                   <a:srgbClr val="F2C8CD"/>
                 </a:solidFill>
               </a:rPr>
-              <a:t>Generated 15/10/2026, 16:28:32</a:t>
+              <a:t>Generated 16/10/2026, 11:24:14</a:t>
             </a:r>
             <a:endParaRPr lang="en-US" sz="900" dirty="0"/>
           </a:p>
@@ -3863,7 +3863,7 @@
                   <a:srgbClr val="667085"/>
                 </a:solidFill>
               </a:rPr>
-              <a:t>Generated 15/10/2026, 16:28:32  |  2</a:t>
+              <a:t>Generated 16/10/2026, 11:24:14  |  2</a:t>
             </a:r>
             <a:endParaRPr lang="en-US" sz="750" dirty="0"/>
           </a:p>
@@ -5777,7 +5777,7 @@
                   <a:srgbClr val="667085"/>
                 </a:solidFill>
               </a:rPr>
-              <a:t>Generated 15/10/2026, 16:28:32  |  3</a:t>
+              <a:t>Generated 16/10/2026, 11:24:14  |  3</a:t>
             </a:r>
             <a:endParaRPr lang="en-US" sz="750" dirty="0"/>
           </a:p>
@@ -6669,7 +6669,7 @@
                   <a:srgbClr val="667085"/>
                 </a:solidFill>
               </a:rPr>
-              <a:t>Generated 15/10/2026, 16:28:32  |  4</a:t>
+              <a:t>Generated 16/10/2026, 11:24:14  |  4</a:t>
             </a:r>
             <a:endParaRPr lang="en-US" sz="750" dirty="0"/>
           </a:p>
@@ -8780,7 +8780,7 @@
                   <a:srgbClr val="667085"/>
                 </a:solidFill>
               </a:rPr>
-              <a:t>Generated 15/10/2026, 16:28:32  |  5</a:t>
+              <a:t>Generated 16/10/2026, 11:24:14  |  5</a:t>
             </a:r>
             <a:endParaRPr lang="en-US" sz="750" dirty="0"/>
           </a:p>
@@ -9153,7 +9153,7 @@
                   <a:srgbClr val="667085"/>
                 </a:solidFill>
               </a:rPr>
-              <a:t>Generated 15/10/2026, 16:28:32  |  6</a:t>
+              <a:t>Generated 16/10/2026, 11:24:14  |  6</a:t>
             </a:r>
             <a:endParaRPr lang="en-US" sz="750" dirty="0"/>
           </a:p>
@@ -10982,7 +10982,7 @@
                   <a:srgbClr val="667085"/>
                 </a:solidFill>
               </a:rPr>
-              <a:t>Generated 15/10/2026, 16:28:32  |  7</a:t>
+              <a:t>Generated 16/10/2026, 11:24:14  |  7</a:t>
             </a:r>
             <a:endParaRPr lang="en-US" sz="750" dirty="0"/>
           </a:p>
@@ -11358,7 +11358,7 @@
                   <a:srgbClr val="667085"/>
                 </a:solidFill>
               </a:rPr>
-              <a:t>Generated 15/10/2026, 16:28:32  |  8</a:t>
+              <a:t>Generated 16/10/2026, 11:24:14  |  8</a:t>
             </a:r>
             <a:endParaRPr lang="en-US" sz="750" dirty="0"/>
           </a:p>

</xml_diff>